<commit_message>
Deck: show the live agent's head-to-head odds from the BigQuery ML model
Slide 4's agent box now shows the live Front Office Analyst answering
"Villanova vs Duke on a neutral court?" from p_matchup (rating-only win
model): Villanova 66.0%, Duke 34.0%, one game rather than title odds.

The Data Agent is deployed (texas-longhorns-front-office-analyst, 9
tables including p_matchup), so slide 3 marks it live and A5/A8 describe
it; Looker Studio stays in progress. Speaker notes updated (~710 words).

Co-Authored-By: Claude Opus 5 <noreply@anthropic.com>
Claude-Session: https://claude.ai/code/session_0167mXuwtgqNpBoMbXwDajYc
</commit_message>
<xml_diff>
--- a/deck/NCAA_Briefing_5min.pptx
+++ b/deck/NCAA_Briefing_5min.pptx
@@ -1220,7 +1220,7 @@
           <a:p>
             <a:r>
               <a:rPr lang="en-US" dirty="0"/>
-              <a:t>ARCHITECTURE (1 min 15s). Read left to right. Raw NCAA tables and Knowledge Catalog scans come in; one dbt project cleans them, tests them, and builds a report card for every team and season. The intelligence layer is all in BigQuery: a BQML model predicts any single matchup, we project every team into next season and build a likely field of 68, a pure-SQL simulation plays that bracket ten thousand times, and AI.GENERATE writes scouting reports. On top, the Data Agent and the Looker report are being built now on these marts, and Gemini Enterprise is the target front door. Three choices, and why: compute stays next to the data, so governance holds. Every answer traces to SQL, and Gemini sees numbers, never names, so it cannot lean on what it knows about 2019. And everything rebuilds from code: one command for the pipeline, one for the Gemini outputs, and 322 dbt tests pass.</a:t>
+              <a:t>ARCHITECTURE (1 min 15s). Read left to right. Raw NCAA tables and Knowledge Catalog scans come in; one dbt project cleans them, tests them, and builds a report card for every team and season. The intelligence layer is all in BigQuery: a BQML model predicts any single matchup, we project every team into next season and build a likely field of 68, a pure-SQL simulation plays that bracket ten thousand times, and AI.GENERATE writes scouting reports. On top, the Data Agent is live on these marts and on the BigQuery ML model's head-to-head odds; the Looker report is being built, and Gemini Enterprise is the target front door. Three choices, and why: compute stays next to the data, so governance holds. Every answer traces to SQL, and Gemini sees numbers, never names, so it cannot lean on what it knows about 2019. And everything rebuilds from code: one command for the pipeline, one for the Gemini outputs, and 322 dbt tests pass.</a:t>
             </a:r>
             <a:endParaRPr lang="en-US" dirty="0"/>
           </a:p>
@@ -1308,7 +1308,7 @@
           <a:p>
             <a:r>
               <a:rPr lang="en-US" dirty="0"/>
-              <a:t>WHY TRUST IT (1 min). A forecast is only worth something if it beats the simple answers. We replayed the 2015, 2016 and 2017 tournaments, 201 games, using only games played before each one. Log loss punishes confident wrong calls. Our model's error was 0.524, against 0.574 for "the better seed always wins" and 0.703 for "the better record always wins". It beat both baselines in all three years, and called 72 percent of games. The forecast uses the ratings-only version, which scored 0.526. In Villanova's 2017-18 profile, the model weighs adjusted offense, adjusted scoring margin, and strength of schedule most. The next-season projection also beat simply carrying ratings forward, RMSE 6.49 against 7.63. And the rehearsed agent answer, verified in SQL, shows the real champions ranked fourth, sixth and third in our pre-tournament odds.</a:t>
+              <a:t>WHY TRUST IT (1 min). A forecast is only worth something if it beats the simple answers. We replayed the 2015, 2016 and 2017 tournaments, 201 games, using only games played before each one. Our model's error was 0.524, against 0.574 for "the better seed always wins" and 0.703 for "the better record always wins". It beat both baselines in all three years. The forecast uses the ratings-only version, which scored 0.526. In Villanova's 2017-18 profile, the model weighs adjusted offense, adjusted scoring margin, and strength of schedule most. The next-season projection also beat simply carrying ratings forward, RMSE 6.49 against 7.63. And the live agent answers head-to-head questions straight from the BigQuery ML model: Villanova beats Duke 66 percent of the time in a single game on a neutral court.</a:t>
             </a:r>
             <a:endParaRPr lang="en-US" dirty="0"/>
           </a:p>
@@ -4431,7 +4431,7 @@
                 <a:ea typeface="Arial" pitchFamily="34" charset="-122"/>
                 <a:cs typeface="Arial" pitchFamily="34" charset="-120"/>
               </a:rPr>
-              <a:t>Agent in progress; 8 SQL-verified Q&amp;A ready in mart_agent_qa</a:t>
+              <a:t>Agent live: 9 tables incl. BQML head-to-head odds; 10 verified examples</a:t>
             </a:r>
             <a:endParaRPr lang="en-US" sz="1050" dirty="0"/>
           </a:p>
@@ -7247,7 +7247,7 @@
                           <a:ea typeface="Arial" pitchFamily="34" charset="-122"/>
                           <a:cs typeface="Arial" pitchFamily="34" charset="-120"/>
                         </a:rPr>
-                        <a:t>BQML with backtests, in-warehouse AI.GENERATE, SQL-verified agent Q&amp;A</a:t>
+                        <a:t>BQML with backtests, in-warehouse AI.GENERATE, live agent on BQML outputs</a:t>
                       </a:r>
                       <a:endParaRPr lang="en-US" sz="1100" dirty="0">
                         <a:latin typeface="Arial" charset="0"/>
@@ -7315,7 +7315,7 @@
                           <a:ea typeface="Arial" pitchFamily="34" charset="-122"/>
                           <a:cs typeface="Arial" pitchFamily="34" charset="-120"/>
                         </a:rPr>
-                        <a:t>Backtest scorecard, agent Q&amp;A</a:t>
+                        <a:t>Backtest scorecard, head-to-head Q&amp;A</a:t>
                       </a:r>
                       <a:endParaRPr lang="en-US" sz="1100" dirty="0">
                         <a:latin typeface="Arial" charset="0"/>
@@ -11255,14 +11255,9 @@
             </a:avLst>
           </a:prstGeom>
           <a:solidFill>
-            <a:srgbClr val="FFFFFF"/>
+            <a:srgbClr val="13161C"/>
           </a:solidFill>
-          <a:ln w="15875">
-            <a:solidFill>
-              <a:srgbClr val="BF5700"/>
-            </a:solidFill>
-            <a:prstDash val="dash"/>
-          </a:ln>
+          <a:ln/>
         </p:spPr>
       </p:sp>
       <p:sp>
@@ -11292,7 +11287,7 @@
             <a:r>
               <a:rPr lang="en-US" sz="1100" b="1" dirty="0">
                 <a:solidFill>
-                  <a:srgbClr val="13161C"/>
+                  <a:srgbClr val="FFFFFF"/>
                 </a:solidFill>
                 <a:latin typeface="Arial" pitchFamily="34" charset="0"/>
                 <a:ea typeface="Arial" pitchFamily="34" charset="-122"/>
@@ -11309,13 +11304,13 @@
             <a:r>
               <a:rPr lang="en-US" sz="900" dirty="0">
                 <a:solidFill>
-                  <a:srgbClr val="BF5700"/>
-                </a:solidFill>
-                <a:latin typeface="Arial" pitchFamily="34" charset="0"/>
-                <a:ea typeface="Arial" pitchFamily="34" charset="-122"/>
-                <a:cs typeface="Arial" pitchFamily="34" charset="-120"/>
-              </a:rPr>
-              <a:t>Agents Hub · in progress</a:t>
+                  <a:srgbClr val="F07F2A"/>
+                </a:solidFill>
+                <a:latin typeface="Arial" pitchFamily="34" charset="0"/>
+                <a:ea typeface="Arial" pitchFamily="34" charset="-122"/>
+                <a:cs typeface="Arial" pitchFamily="34" charset="-120"/>
+              </a:rPr>
+              <a:t>Agents Hub · live</a:t>
             </a:r>
             <a:endParaRPr lang="en-US" sz="1100" dirty="0"/>
           </a:p>
@@ -12957,7 +12952,7 @@
                 <a:ea typeface="Arial" pitchFamily="34" charset="-122"/>
                 <a:cs typeface="Arial" pitchFamily="34" charset="-120"/>
               </a:rPr>
-              <a:t>FRONT OFFICE ANALYST · REHEARSED Q&amp;A</a:t>
+              <a:t>ASK THE FRONT OFFICE ANALYST · LIVE</a:t>
             </a:r>
             <a:endParaRPr lang="en-US" sz="850" dirty="0"/>
           </a:p>
@@ -12971,8 +12966,8 @@
         </p:nvSpPr>
         <p:spPr>
           <a:xfrm>
-            <a:off x="6217920" y="3639312"/>
-            <a:ext cx="2240280" cy="274320"/>
+            <a:off x="5943600" y="3639312"/>
+            <a:ext cx="2514600" cy="274320"/>
           </a:xfrm>
           <a:prstGeom prst="roundRect">
             <a:avLst>
@@ -12993,8 +12988,8 @@
         </p:nvSpPr>
         <p:spPr>
           <a:xfrm>
-            <a:off x="6217920" y="3639312"/>
-            <a:ext cx="2240280" cy="274320"/>
+            <a:off x="5943600" y="3639312"/>
+            <a:ext cx="2514600" cy="274320"/>
           </a:xfrm>
           <a:prstGeom prst="rect">
             <a:avLst/>
@@ -13018,7 +13013,7 @@
                 <a:ea typeface="Arial" pitchFamily="34" charset="-122"/>
                 <a:cs typeface="Arial" pitchFamily="34" charset="-120"/>
               </a:rPr>
-              <a:t>Did you see past champions coming?</a:t>
+              <a:t>Villanova vs Duke on a neutral court?</a:t>
             </a:r>
             <a:endParaRPr lang="en-US" sz="1000" dirty="0"/>
           </a:p>
@@ -13057,7 +13052,7 @@
                 <a:ea typeface="Arial" pitchFamily="34" charset="-122"/>
                 <a:cs typeface="Arial" pitchFamily="34" charset="-120"/>
               </a:rPr>
-              <a:t>Before each tournament, Duke ranked 4th (10.3%), Villanova 6th (5.2%) and North Carolina 3rd (11.7%) in our title odds.</a:t>
+              <a:t>Villanova wins 66.0% of single games against Duke, and Duke wins 34.0%. That is one game, not title odds.</a:t>
             </a:r>
             <a:endParaRPr lang="en-US" sz="1050" dirty="0"/>
           </a:p>
@@ -13096,7 +13091,7 @@
                 <a:ea typeface="Arial" pitchFamily="34" charset="-122"/>
                 <a:cs typeface="Arial" pitchFamily="34" charset="-120"/>
               </a:rPr>
-              <a:t>↳ SQL-verified answer, stored in mart_agent_qa</a:t>
+              <a:t>↳ BigQuery ML head-to-head odds (p_matchup), via SQL</a:t>
             </a:r>
             <a:endParaRPr lang="en-US" sz="900" dirty="0"/>
           </a:p>

</xml_diff>